<commit_message>
Real eval on 10 queries: v1/v2 MiniMax, v3 DeepSeek; agent fixes found by eval
- Plan truncated by max_tokens: raise limit, ask the agent to compact and resubmit
- days passed as a JSON string: parse nested fields
- Infeasible requests looped on tool calls: prompt rule + last-steps nudge
- Results: quality 0.64 -> 0.75 -> 1.00, tokens 88k -> 52k -> 32k, $0.005/query on v3
- README, report and deck updated with real numbers

Co-Authored-By: Claude Opus 5.5 <noreply@anthropic.com>
</commit_message>
<xml_diff>
--- a/presentation/Amba_Travel_AI.pptx
+++ b/presentation/Amba_Travel_AI.pptx
@@ -121,18 +121,18 @@
   <p:extLst>
     <p:ext uri="{521415D9-36F7-43E2-AB2F-B90AF26B5E84}">
       <p14:sectionLst xmlns:p14="http://schemas.microsoft.com/office/powerpoint/2010/main">
-        <p14:section name="Начало" id="{19ff1243-ed7a-812e-75c9-1041f6816633}">
+        <p14:section name="Начало" id="{55f83ce5-2c8c-0d70-bc69-07f9a223233c}">
           <p14:sldIdLst>
             <p14:sldId id="256"/>
           </p14:sldIdLst>
         </p14:section>
-        <p14:section name="Задача" id="{d7defa1a-5c26-224d-f83e-3188c6ec6a67}">
+        <p14:section name="Задача" id="{799d44a9-d8c1-e278-987e-670d39e1f5d9}">
           <p14:sldIdLst>
             <p14:sldId id="257"/>
             <p14:sldId id="258"/>
           </p14:sldIdLst>
         </p14:section>
-        <p14:section name="Решение" id="{116757dc-313b-a7b9-632a-4896286fea09}">
+        <p14:section name="Решение" id="{b2829937-d3a1-f9a6-ea09-bf5878568194}">
           <p14:sldIdLst>
             <p14:sldId id="259"/>
             <p14:sldId id="260"/>
@@ -142,19 +142,19 @@
             <p14:sldId id="264"/>
           </p14:sldIdLst>
         </p14:section>
-        <p14:section name="Замеры" id="{961554c5-61f0-2715-9dd3-70a801617162}">
+        <p14:section name="Замеры" id="{f16670f8-69df-c3b5-a63c-b4b78f7c6fd8}">
           <p14:sldIdLst>
             <p14:sldId id="265"/>
             <p14:sldId id="266"/>
             <p14:sldId id="267"/>
           </p14:sldIdLst>
         </p14:section>
-        <p14:section name="Команда" id="{0ac60ffc-1ab5-57bb-10c0-4a63167e7931}">
+        <p14:section name="Команда" id="{ced8fad4-d6ba-eaff-7fb7-bc38dcac5155}">
           <p14:sldIdLst>
             <p14:sldId id="268"/>
           </p14:sldIdLst>
         </p14:section>
-        <p14:section name="Итоги" id="{e3e67cd0-39a5-eb6a-ed05-8b90212319e3}">
+        <p14:section name="Итоги" id="{24763dff-eef9-df12-c23c-cef3725aae67}">
           <p14:sldIdLst>
             <p14:sldId id="269"/>
             <p14:sldId id="270"/>
@@ -257,9 +257,9 @@
           </c:dLbls>
           <c:cat>
             <c:multiLvlStrRef>
-              <c:f>Sheet1!$A$2:$A$3</c:f>
+              <c:f>Sheet1!$A$2:$A$4</c:f>
               <c:multiLvlStrCache>
-                <c:ptCount val="2"/>
+                <c:ptCount val="3"/>
                 <c:lvl>
                   <c:pt idx="0">
                     <c:v>v1</c:v>
@@ -267,21 +267,27 @@
                   <c:pt idx="1">
                     <c:v>v2</c:v>
                   </c:pt>
+                  <c:pt idx="2">
+                    <c:v>v3</c:v>
+                  </c:pt>
                 </c:lvl>
               </c:multiLvlStrCache>
             </c:multiLvlStrRef>
           </c:cat>
           <c:val>
             <c:numRef>
-              <c:f>Sheet1!$B$2:$B$3</c:f>
+              <c:f>Sheet1!$B$2:$B$4</c:f>
               <c:numCache>
                 <c:formatCode>General</c:formatCode>
-                <c:ptCount val="2"/>
+                <c:ptCount val="3"/>
                 <c:pt idx="0">
-                  <c:v>9470</c:v>
+                  <c:v>87860</c:v>
                 </c:pt>
                 <c:pt idx="1">
-                  <c:v>2893</c:v>
+                  <c:v>52098</c:v>
+                </c:pt>
+                <c:pt idx="2">
+                  <c:v>32462</c:v>
                 </c:pt>
               </c:numCache>
             </c:numRef>
@@ -520,9 +526,9 @@
           </c:dLbls>
           <c:cat>
             <c:multiLvlStrRef>
-              <c:f>Sheet1!$A$2:$A$3</c:f>
+              <c:f>Sheet1!$A$2:$A$4</c:f>
               <c:multiLvlStrCache>
-                <c:ptCount val="2"/>
+                <c:ptCount val="3"/>
                 <c:lvl>
                   <c:pt idx="0">
                     <c:v>v1</c:v>
@@ -530,21 +536,27 @@
                   <c:pt idx="1">
                     <c:v>v2</c:v>
                   </c:pt>
+                  <c:pt idx="2">
+                    <c:v>v3</c:v>
+                  </c:pt>
                 </c:lvl>
               </c:multiLvlStrCache>
             </c:multiLvlStrRef>
           </c:cat>
           <c:val>
             <c:numRef>
-              <c:f>Sheet1!$B$2:$B$3</c:f>
+              <c:f>Sheet1!$B$2:$B$4</c:f>
               <c:numCache>
                 <c:formatCode>General</c:formatCode>
-                <c:ptCount val="2"/>
+                <c:ptCount val="3"/>
                 <c:pt idx="0">
-                  <c:v>0.965</c:v>
+                  <c:v>0.643</c:v>
                 </c:pt>
                 <c:pt idx="1">
-                  <c:v>0.965</c:v>
+                  <c:v>0.75</c:v>
+                </c:pt>
+                <c:pt idx="2">
+                  <c:v>1</c:v>
                 </c:pt>
               </c:numCache>
             </c:numRef>
@@ -1092,7 +1104,7 @@
           <a:p>
             <a:r>
               <a:rPr lang="en-US" dirty="0"/>
-              <a:t>Представляем Амбу — тигрёнка-летописца. Это веб-ассистент: пишешь запрос обычными словами, получаешь готовый план поездки по Приморскому краю, оформленный как старорусская грамота. Главное — план не просто сгенерирован, а сверен с реальностью.</a:t>
+              <a:t>Представляем Амбу — тигрёнка-гида. Это веб-ассистент: пишешь запрос обычными словами, получаешь готовый план поездки по Приморскому краю. Главное — план не просто сгенерирован, а сверен с реальностью.</a:t>
             </a:r>
             <a:endParaRPr lang="en-US" dirty="0"/>
           </a:p>
@@ -1268,7 +1280,7 @@
           <a:p>
             <a:r>
               <a:rPr lang="en-US" dirty="0"/>
-              <a:t>Три версии на одном наборе из 20 запросов. v1 — бейзлайн: короткий промпт, сырые ответы тулов. v2 — сжатие контекста, пред-фильтр и цикл исправлений. v3 — тот же пайплайн на лёгкой модели. Смотрим качество, токены и время.</a:t>
+              <a:t>Три версии на одном наборе из 10 запросов. v1 — бейзлайн: короткий промпт, сырые ответы тулов. v2 — сжатие контекста, фильтр и цикл исправлений. v3 — исправления, найденные эвалом, и модель DeepSeek. Смотрим качество, токены и время.</a:t>
             </a:r>
             <a:endParaRPr lang="en-US" dirty="0"/>
           </a:p>
@@ -1356,7 +1368,7 @@
           <a:p>
             <a:r>
               <a:rPr lang="en-US" dirty="0"/>
-              <a:t>Главные выводы по замерам: сжатие контекста резко снижает токены без потери качества, сверка поднимает долю сходящихся планов, лёгкая модель дешевле — цена вопроса видна в таблице.</a:t>
+              <a:t>v1 и v2 — на бесплатной MiniMax, v3 — на DeepSeek с исправлениями. Главные выводы по замерам: сжатие контекста резко снижает токены без потери качества, сверка поднимает долю сходящихся планов, лёгкая модель дешевле — цена вопроса видна в таблице.</a:t>
             </a:r>
             <a:endParaRPr lang="en-US" dirty="0"/>
           </a:p>
@@ -3079,7 +3091,7 @@
                 <a:ea typeface="Arial" pitchFamily="34" charset="-122"/>
                 <a:cs typeface="Arial" pitchFamily="34" charset="-120"/>
               </a:rPr>
-              <a:t>Амба — AI-летописец странствий по Приморью</a:t>
+              <a:t>Амба — AI-гид по Приморью</a:t>
             </a:r>
             <a:endParaRPr lang="en-US" sz="3600" dirty="0"/>
           </a:p>
@@ -3210,7 +3222,7 @@
                 <a:ea typeface="Arial" pitchFamily="34" charset="-122"/>
                 <a:cs typeface="Arial" pitchFamily="34" charset="-120"/>
               </a:rPr>
-              <a:t>Гой еси, путникъ! Куда держимъ путь?</a:t>
+              <a:t>Привет! Куда поедем?</a:t>
             </a:r>
             <a:endParaRPr lang="en-US" sz="1200" dirty="0"/>
           </a:p>
@@ -3312,7 +3324,7 @@
                   <a:schemeClr val="accent1"/>
                 </a:solidFill>
               </a:rPr>
-              <a:t>20</a:t>
+              <a:t>10</a:t>
             </a:r>
             <a:endParaRPr lang="en-US" sz="4800" dirty="0"/>
           </a:p>
@@ -3348,7 +3360,7 @@
                   <a:schemeClr val="tx1"/>
                 </a:solidFill>
               </a:rPr>
-              <a:t>фиксированных запросов</a:t>
+              <a:t>фиксированных запросов в прогоне</a:t>
             </a:r>
             <a:endParaRPr lang="en-US" sz="1300" dirty="0"/>
           </a:p>
@@ -3384,7 +3396,7 @@
                   <a:schemeClr val="accent1"/>
                 </a:solidFill>
               </a:rPr>
-              <a:t>15</a:t>
+              <a:t>7</a:t>
             </a:r>
             <a:endParaRPr lang="en-US" sz="4800" dirty="0"/>
           </a:p>
@@ -3420,7 +3432,7 @@
                   <a:schemeClr val="tx1"/>
                 </a:solidFill>
               </a:rPr>
-              <a:t>поездок: все виды транспорта</a:t>
+              <a:t>поездок: машина, автобус, электричка, велосипед, пешком</a:t>
             </a:r>
             <a:endParaRPr lang="en-US" sz="1300" dirty="0"/>
           </a:p>
@@ -3456,7 +3468,7 @@
                   <a:schemeClr val="accent1"/>
                 </a:solidFill>
               </a:rPr>
-              <a:t>5</a:t>
+              <a:t>3</a:t>
             </a:r>
             <a:endParaRPr lang="en-US" sz="4800" dirty="0"/>
           </a:p>
@@ -3492,7 +3504,7 @@
                   <a:schemeClr val="tx1"/>
                 </a:solidFill>
               </a:rPr>
-              <a:t>нецелевых: другой регион, инъекции, оффтоп</a:t>
+              <a:t>нецелевых: другой регион, «забудь правила», оффтоп</a:t>
             </a:r>
             <a:endParaRPr lang="en-US" sz="1300" dirty="0"/>
           </a:p>
@@ -4606,7 +4618,7 @@
                             <a:srgbClr val="0F2D3A"/>
                           </a:solidFill>
                         </a:rPr>
-                        <a:t>rule-based-planner</a:t>
+                        <a:t>minimax-m3.1-flash:free</a:t>
                       </a:r>
                       <a:endParaRPr lang="en-US" sz="1000" dirty="0"/>
                     </a:p>
@@ -4664,10 +4676,10 @@
                       <a:r>
                         <a:rPr lang="en-US" sz="1100" b="1" dirty="0">
                           <a:solidFill>
-                            <a:srgbClr val="F0641E"/>
+                            <a:srgbClr val="0F2D3A"/>
                           </a:solidFill>
                         </a:rPr>
-                        <a:t>0.96</a:t>
+                        <a:t>0.64</a:t>
                       </a:r>
                       <a:endParaRPr lang="en-US" sz="1100" dirty="0"/>
                     </a:p>
@@ -4728,7 +4740,7 @@
                             <a:srgbClr val="0F2D3A"/>
                           </a:solidFill>
                         </a:rPr>
-                        <a:t>95%</a:t>
+                        <a:t>70%</a:t>
                       </a:r>
                       <a:endParaRPr lang="en-US" sz="1100" dirty="0"/>
                     </a:p>
@@ -4789,7 +4801,7 @@
                             <a:srgbClr val="0F2D3A"/>
                           </a:solidFill>
                         </a:rPr>
-                        <a:t>87%</a:t>
+                        <a:t>43%</a:t>
                       </a:r>
                       <a:endParaRPr lang="en-US" sz="1100" dirty="0"/>
                     </a:p>
@@ -4850,7 +4862,7 @@
                             <a:srgbClr val="0F2D3A"/>
                           </a:solidFill>
                         </a:rPr>
-                        <a:t>9 470</a:t>
+                        <a:t>87 860</a:t>
                       </a:r>
                       <a:endParaRPr lang="en-US" sz="1100" dirty="0"/>
                     </a:p>
@@ -4972,7 +4984,7 @@
                             <a:srgbClr val="0F2D3A"/>
                           </a:solidFill>
                         </a:rPr>
-                        <a:t>3,35</a:t>
+                        <a:t>68,47</a:t>
                       </a:r>
                       <a:endParaRPr lang="en-US" sz="1100" dirty="0"/>
                     </a:p>
@@ -5096,7 +5108,7 @@
                             <a:srgbClr val="0F2D3A"/>
                           </a:solidFill>
                         </a:rPr>
-                        <a:t>rule-based-planner</a:t>
+                        <a:t>minimax-m3.1-flash:free</a:t>
                       </a:r>
                       <a:endParaRPr lang="en-US" sz="1000" dirty="0"/>
                     </a:p>
@@ -5154,10 +5166,10 @@
                       <a:r>
                         <a:rPr lang="en-US" sz="1100" b="1" dirty="0">
                           <a:solidFill>
-                            <a:srgbClr val="F0641E"/>
+                            <a:srgbClr val="0F2D3A"/>
                           </a:solidFill>
                         </a:rPr>
-                        <a:t>0.96</a:t>
+                        <a:t>0.75</a:t>
                       </a:r>
                       <a:endParaRPr lang="en-US" sz="1100" dirty="0"/>
                     </a:p>
@@ -5218,7 +5230,7 @@
                             <a:srgbClr val="0F2D3A"/>
                           </a:solidFill>
                         </a:rPr>
-                        <a:t>95%</a:t>
+                        <a:t>80%</a:t>
                       </a:r>
                       <a:endParaRPr lang="en-US" sz="1100" dirty="0"/>
                     </a:p>
@@ -5279,7 +5291,7 @@
                             <a:srgbClr val="0F2D3A"/>
                           </a:solidFill>
                         </a:rPr>
-                        <a:t>87%</a:t>
+                        <a:t>57%</a:t>
                       </a:r>
                       <a:endParaRPr lang="en-US" sz="1100" dirty="0"/>
                     </a:p>
@@ -5340,7 +5352,7 @@
                             <a:srgbClr val="0F2D3A"/>
                           </a:solidFill>
                         </a:rPr>
-                        <a:t>2 893</a:t>
+                        <a:t>52 098</a:t>
                       </a:r>
                       <a:endParaRPr lang="en-US" sz="1100" dirty="0"/>
                     </a:p>
@@ -5462,7 +5474,7 @@
                             <a:srgbClr val="0F2D3A"/>
                           </a:solidFill>
                         </a:rPr>
-                        <a:t>0,37</a:t>
+                        <a:t>65,65</a:t>
                       </a:r>
                       <a:endParaRPr lang="en-US" sz="1100" dirty="0"/>
                     </a:p>
@@ -5506,6 +5518,496 @@
                     </a:lnB>
                     <a:solidFill>
                       <a:srgbClr val="FFFFFF"/>
+                    </a:solidFill>
+                  </a:tcPr>
+                </a:tc>
+              </a:tr>
+              <a:tr h="384048">
+                <a:tc>
+                  <a:txBody>
+                    <a:bodyPr/>
+                    <a:lstStyle/>
+                    <a:p>
+                      <a:pPr algn="l" indent="0" marL="0">
+                        <a:buNone/>
+                      </a:pPr>
+                      <a:r>
+                        <a:rPr lang="en-US" sz="1100" b="1" dirty="0">
+                          <a:solidFill>
+                            <a:srgbClr val="0F2D3A"/>
+                          </a:solidFill>
+                        </a:rPr>
+                        <a:t>v3 · Финальная: v2 + исправления + DeepSeek</a:t>
+                      </a:r>
+                      <a:endParaRPr lang="en-US" sz="1100" dirty="0"/>
+                    </a:p>
+                  </a:txBody>
+                  <a:tcPr marL="45720" marR="45720" marT="45720" marB="45720" anchor="ctr">
+                    <a:lnL w="6350" cap="flat" cmpd="sng" algn="ctr">
+                      <a:solidFill>
+                        <a:srgbClr val="D5E0E3"/>
+                      </a:solidFill>
+                      <a:prstDash val="solid"/>
+                      <a:round/>
+                      <a:headEnd type="none" w="med" len="med"/>
+                      <a:tailEnd type="none" w="med" len="med"/>
+                    </a:lnL>
+                    <a:lnR w="6350" cap="flat" cmpd="sng" algn="ctr">
+                      <a:solidFill>
+                        <a:srgbClr val="D5E0E3"/>
+                      </a:solidFill>
+                      <a:prstDash val="solid"/>
+                      <a:round/>
+                      <a:headEnd type="none" w="med" len="med"/>
+                      <a:tailEnd type="none" w="med" len="med"/>
+                    </a:lnR>
+                    <a:lnT w="6350" cap="flat" cmpd="sng" algn="ctr">
+                      <a:solidFill>
+                        <a:srgbClr val="D5E0E3"/>
+                      </a:solidFill>
+                      <a:prstDash val="solid"/>
+                      <a:round/>
+                      <a:headEnd type="none" w="med" len="med"/>
+                      <a:tailEnd type="none" w="med" len="med"/>
+                    </a:lnT>
+                    <a:lnB w="6350" cap="flat" cmpd="sng" algn="ctr">
+                      <a:solidFill>
+                        <a:srgbClr val="D5E0E3"/>
+                      </a:solidFill>
+                      <a:prstDash val="solid"/>
+                      <a:round/>
+                      <a:headEnd type="none" w="med" len="med"/>
+                      <a:tailEnd type="none" w="med" len="med"/>
+                    </a:lnB>
+                    <a:solidFill>
+                      <a:srgbClr val="F3F6F7"/>
+                    </a:solidFill>
+                  </a:tcPr>
+                </a:tc>
+                <a:tc>
+                  <a:txBody>
+                    <a:bodyPr/>
+                    <a:lstStyle/>
+                    <a:p>
+                      <a:pPr algn="ctr" indent="0" marL="0">
+                        <a:buNone/>
+                      </a:pPr>
+                      <a:r>
+                        <a:rPr lang="en-US" sz="1000" dirty="0">
+                          <a:solidFill>
+                            <a:srgbClr val="0F2D3A"/>
+                          </a:solidFill>
+                        </a:rPr>
+                        <a:t>deepseek-v4.1-flash</a:t>
+                      </a:r>
+                      <a:endParaRPr lang="en-US" sz="1000" dirty="0"/>
+                    </a:p>
+                  </a:txBody>
+                  <a:tcPr marL="45720" marR="45720" marT="45720" marB="45720" anchor="ctr">
+                    <a:lnL w="6350" cap="flat" cmpd="sng" algn="ctr">
+                      <a:solidFill>
+                        <a:srgbClr val="D5E0E3"/>
+                      </a:solidFill>
+                      <a:prstDash val="solid"/>
+                      <a:round/>
+                      <a:headEnd type="none" w="med" len="med"/>
+                      <a:tailEnd type="none" w="med" len="med"/>
+                    </a:lnL>
+                    <a:lnR w="6350" cap="flat" cmpd="sng" algn="ctr">
+                      <a:solidFill>
+                        <a:srgbClr val="D5E0E3"/>
+                      </a:solidFill>
+                      <a:prstDash val="solid"/>
+                      <a:round/>
+                      <a:headEnd type="none" w="med" len="med"/>
+                      <a:tailEnd type="none" w="med" len="med"/>
+                    </a:lnR>
+                    <a:lnT w="6350" cap="flat" cmpd="sng" algn="ctr">
+                      <a:solidFill>
+                        <a:srgbClr val="D5E0E3"/>
+                      </a:solidFill>
+                      <a:prstDash val="solid"/>
+                      <a:round/>
+                      <a:headEnd type="none" w="med" len="med"/>
+                      <a:tailEnd type="none" w="med" len="med"/>
+                    </a:lnT>
+                    <a:lnB w="6350" cap="flat" cmpd="sng" algn="ctr">
+                      <a:solidFill>
+                        <a:srgbClr val="D5E0E3"/>
+                      </a:solidFill>
+                      <a:prstDash val="solid"/>
+                      <a:round/>
+                      <a:headEnd type="none" w="med" len="med"/>
+                      <a:tailEnd type="none" w="med" len="med"/>
+                    </a:lnB>
+                    <a:solidFill>
+                      <a:srgbClr val="F3F6F7"/>
+                    </a:solidFill>
+                  </a:tcPr>
+                </a:tc>
+                <a:tc>
+                  <a:txBody>
+                    <a:bodyPr/>
+                    <a:lstStyle/>
+                    <a:p>
+                      <a:pPr algn="ctr" indent="0" marL="0">
+                        <a:buNone/>
+                      </a:pPr>
+                      <a:r>
+                        <a:rPr lang="en-US" sz="1100" b="1" dirty="0">
+                          <a:solidFill>
+                            <a:srgbClr val="F0641E"/>
+                          </a:solidFill>
+                        </a:rPr>
+                        <a:t>1.00</a:t>
+                      </a:r>
+                      <a:endParaRPr lang="en-US" sz="1100" dirty="0"/>
+                    </a:p>
+                  </a:txBody>
+                  <a:tcPr marL="45720" marR="45720" marT="45720" marB="45720" anchor="ctr">
+                    <a:lnL w="6350" cap="flat" cmpd="sng" algn="ctr">
+                      <a:solidFill>
+                        <a:srgbClr val="D5E0E3"/>
+                      </a:solidFill>
+                      <a:prstDash val="solid"/>
+                      <a:round/>
+                      <a:headEnd type="none" w="med" len="med"/>
+                      <a:tailEnd type="none" w="med" len="med"/>
+                    </a:lnL>
+                    <a:lnR w="6350" cap="flat" cmpd="sng" algn="ctr">
+                      <a:solidFill>
+                        <a:srgbClr val="D5E0E3"/>
+                      </a:solidFill>
+                      <a:prstDash val="solid"/>
+                      <a:round/>
+                      <a:headEnd type="none" w="med" len="med"/>
+                      <a:tailEnd type="none" w="med" len="med"/>
+                    </a:lnR>
+                    <a:lnT w="6350" cap="flat" cmpd="sng" algn="ctr">
+                      <a:solidFill>
+                        <a:srgbClr val="D5E0E3"/>
+                      </a:solidFill>
+                      <a:prstDash val="solid"/>
+                      <a:round/>
+                      <a:headEnd type="none" w="med" len="med"/>
+                      <a:tailEnd type="none" w="med" len="med"/>
+                    </a:lnT>
+                    <a:lnB w="6350" cap="flat" cmpd="sng" algn="ctr">
+                      <a:solidFill>
+                        <a:srgbClr val="D5E0E3"/>
+                      </a:solidFill>
+                      <a:prstDash val="solid"/>
+                      <a:round/>
+                      <a:headEnd type="none" w="med" len="med"/>
+                      <a:tailEnd type="none" w="med" len="med"/>
+                    </a:lnB>
+                    <a:solidFill>
+                      <a:srgbClr val="F3F6F7"/>
+                    </a:solidFill>
+                  </a:tcPr>
+                </a:tc>
+                <a:tc>
+                  <a:txBody>
+                    <a:bodyPr/>
+                    <a:lstStyle/>
+                    <a:p>
+                      <a:pPr algn="ctr" indent="0" marL="0">
+                        <a:buNone/>
+                      </a:pPr>
+                      <a:r>
+                        <a:rPr lang="en-US" sz="1100" dirty="0">
+                          <a:solidFill>
+                            <a:srgbClr val="0F2D3A"/>
+                          </a:solidFill>
+                        </a:rPr>
+                        <a:t>100%</a:t>
+                      </a:r>
+                      <a:endParaRPr lang="en-US" sz="1100" dirty="0"/>
+                    </a:p>
+                  </a:txBody>
+                  <a:tcPr marL="45720" marR="45720" marT="45720" marB="45720" anchor="ctr">
+                    <a:lnL w="6350" cap="flat" cmpd="sng" algn="ctr">
+                      <a:solidFill>
+                        <a:srgbClr val="D5E0E3"/>
+                      </a:solidFill>
+                      <a:prstDash val="solid"/>
+                      <a:round/>
+                      <a:headEnd type="none" w="med" len="med"/>
+                      <a:tailEnd type="none" w="med" len="med"/>
+                    </a:lnL>
+                    <a:lnR w="6350" cap="flat" cmpd="sng" algn="ctr">
+                      <a:solidFill>
+                        <a:srgbClr val="D5E0E3"/>
+                      </a:solidFill>
+                      <a:prstDash val="solid"/>
+                      <a:round/>
+                      <a:headEnd type="none" w="med" len="med"/>
+                      <a:tailEnd type="none" w="med" len="med"/>
+                    </a:lnR>
+                    <a:lnT w="6350" cap="flat" cmpd="sng" algn="ctr">
+                      <a:solidFill>
+                        <a:srgbClr val="D5E0E3"/>
+                      </a:solidFill>
+                      <a:prstDash val="solid"/>
+                      <a:round/>
+                      <a:headEnd type="none" w="med" len="med"/>
+                      <a:tailEnd type="none" w="med" len="med"/>
+                    </a:lnT>
+                    <a:lnB w="6350" cap="flat" cmpd="sng" algn="ctr">
+                      <a:solidFill>
+                        <a:srgbClr val="D5E0E3"/>
+                      </a:solidFill>
+                      <a:prstDash val="solid"/>
+                      <a:round/>
+                      <a:headEnd type="none" w="med" len="med"/>
+                      <a:tailEnd type="none" w="med" len="med"/>
+                    </a:lnB>
+                    <a:solidFill>
+                      <a:srgbClr val="F3F6F7"/>
+                    </a:solidFill>
+                  </a:tcPr>
+                </a:tc>
+                <a:tc>
+                  <a:txBody>
+                    <a:bodyPr/>
+                    <a:lstStyle/>
+                    <a:p>
+                      <a:pPr algn="ctr" indent="0" marL="0">
+                        <a:buNone/>
+                      </a:pPr>
+                      <a:r>
+                        <a:rPr lang="en-US" sz="1100" dirty="0">
+                          <a:solidFill>
+                            <a:srgbClr val="0F2D3A"/>
+                          </a:solidFill>
+                        </a:rPr>
+                        <a:t>100%</a:t>
+                      </a:r>
+                      <a:endParaRPr lang="en-US" sz="1100" dirty="0"/>
+                    </a:p>
+                  </a:txBody>
+                  <a:tcPr marL="45720" marR="45720" marT="45720" marB="45720" anchor="ctr">
+                    <a:lnL w="6350" cap="flat" cmpd="sng" algn="ctr">
+                      <a:solidFill>
+                        <a:srgbClr val="D5E0E3"/>
+                      </a:solidFill>
+                      <a:prstDash val="solid"/>
+                      <a:round/>
+                      <a:headEnd type="none" w="med" len="med"/>
+                      <a:tailEnd type="none" w="med" len="med"/>
+                    </a:lnL>
+                    <a:lnR w="6350" cap="flat" cmpd="sng" algn="ctr">
+                      <a:solidFill>
+                        <a:srgbClr val="D5E0E3"/>
+                      </a:solidFill>
+                      <a:prstDash val="solid"/>
+                      <a:round/>
+                      <a:headEnd type="none" w="med" len="med"/>
+                      <a:tailEnd type="none" w="med" len="med"/>
+                    </a:lnR>
+                    <a:lnT w="6350" cap="flat" cmpd="sng" algn="ctr">
+                      <a:solidFill>
+                        <a:srgbClr val="D5E0E3"/>
+                      </a:solidFill>
+                      <a:prstDash val="solid"/>
+                      <a:round/>
+                      <a:headEnd type="none" w="med" len="med"/>
+                      <a:tailEnd type="none" w="med" len="med"/>
+                    </a:lnT>
+                    <a:lnB w="6350" cap="flat" cmpd="sng" algn="ctr">
+                      <a:solidFill>
+                        <a:srgbClr val="D5E0E3"/>
+                      </a:solidFill>
+                      <a:prstDash val="solid"/>
+                      <a:round/>
+                      <a:headEnd type="none" w="med" len="med"/>
+                      <a:tailEnd type="none" w="med" len="med"/>
+                    </a:lnB>
+                    <a:solidFill>
+                      <a:srgbClr val="F3F6F7"/>
+                    </a:solidFill>
+                  </a:tcPr>
+                </a:tc>
+                <a:tc>
+                  <a:txBody>
+                    <a:bodyPr/>
+                    <a:lstStyle/>
+                    <a:p>
+                      <a:pPr algn="ctr" indent="0" marL="0">
+                        <a:buNone/>
+                      </a:pPr>
+                      <a:r>
+                        <a:rPr lang="en-US" sz="1100" dirty="0">
+                          <a:solidFill>
+                            <a:srgbClr val="0F2D3A"/>
+                          </a:solidFill>
+                        </a:rPr>
+                        <a:t>32 462</a:t>
+                      </a:r>
+                      <a:endParaRPr lang="en-US" sz="1100" dirty="0"/>
+                    </a:p>
+                  </a:txBody>
+                  <a:tcPr marL="45720" marR="45720" marT="45720" marB="45720" anchor="ctr">
+                    <a:lnL w="6350" cap="flat" cmpd="sng" algn="ctr">
+                      <a:solidFill>
+                        <a:srgbClr val="D5E0E3"/>
+                      </a:solidFill>
+                      <a:prstDash val="solid"/>
+                      <a:round/>
+                      <a:headEnd type="none" w="med" len="med"/>
+                      <a:tailEnd type="none" w="med" len="med"/>
+                    </a:lnL>
+                    <a:lnR w="6350" cap="flat" cmpd="sng" algn="ctr">
+                      <a:solidFill>
+                        <a:srgbClr val="D5E0E3"/>
+                      </a:solidFill>
+                      <a:prstDash val="solid"/>
+                      <a:round/>
+                      <a:headEnd type="none" w="med" len="med"/>
+                      <a:tailEnd type="none" w="med" len="med"/>
+                    </a:lnR>
+                    <a:lnT w="6350" cap="flat" cmpd="sng" algn="ctr">
+                      <a:solidFill>
+                        <a:srgbClr val="D5E0E3"/>
+                      </a:solidFill>
+                      <a:prstDash val="solid"/>
+                      <a:round/>
+                      <a:headEnd type="none" w="med" len="med"/>
+                      <a:tailEnd type="none" w="med" len="med"/>
+                    </a:lnT>
+                    <a:lnB w="6350" cap="flat" cmpd="sng" algn="ctr">
+                      <a:solidFill>
+                        <a:srgbClr val="D5E0E3"/>
+                      </a:solidFill>
+                      <a:prstDash val="solid"/>
+                      <a:round/>
+                      <a:headEnd type="none" w="med" len="med"/>
+                      <a:tailEnd type="none" w="med" len="med"/>
+                    </a:lnB>
+                    <a:solidFill>
+                      <a:srgbClr val="F3F6F7"/>
+                    </a:solidFill>
+                  </a:tcPr>
+                </a:tc>
+                <a:tc>
+                  <a:txBody>
+                    <a:bodyPr/>
+                    <a:lstStyle/>
+                    <a:p>
+                      <a:pPr algn="ctr" indent="0" marL="0">
+                        <a:buNone/>
+                      </a:pPr>
+                      <a:r>
+                        <a:rPr lang="en-US" sz="1100" dirty="0">
+                          <a:solidFill>
+                            <a:srgbClr val="0F2D3A"/>
+                          </a:solidFill>
+                        </a:rPr>
+                        <a:t>0.0052</a:t>
+                      </a:r>
+                      <a:endParaRPr lang="en-US" sz="1100" dirty="0"/>
+                    </a:p>
+                  </a:txBody>
+                  <a:tcPr marL="45720" marR="45720" marT="45720" marB="45720" anchor="ctr">
+                    <a:lnL w="6350" cap="flat" cmpd="sng" algn="ctr">
+                      <a:solidFill>
+                        <a:srgbClr val="D5E0E3"/>
+                      </a:solidFill>
+                      <a:prstDash val="solid"/>
+                      <a:round/>
+                      <a:headEnd type="none" w="med" len="med"/>
+                      <a:tailEnd type="none" w="med" len="med"/>
+                    </a:lnL>
+                    <a:lnR w="6350" cap="flat" cmpd="sng" algn="ctr">
+                      <a:solidFill>
+                        <a:srgbClr val="D5E0E3"/>
+                      </a:solidFill>
+                      <a:prstDash val="solid"/>
+                      <a:round/>
+                      <a:headEnd type="none" w="med" len="med"/>
+                      <a:tailEnd type="none" w="med" len="med"/>
+                    </a:lnR>
+                    <a:lnT w="6350" cap="flat" cmpd="sng" algn="ctr">
+                      <a:solidFill>
+                        <a:srgbClr val="D5E0E3"/>
+                      </a:solidFill>
+                      <a:prstDash val="solid"/>
+                      <a:round/>
+                      <a:headEnd type="none" w="med" len="med"/>
+                      <a:tailEnd type="none" w="med" len="med"/>
+                    </a:lnT>
+                    <a:lnB w="6350" cap="flat" cmpd="sng" algn="ctr">
+                      <a:solidFill>
+                        <a:srgbClr val="D5E0E3"/>
+                      </a:solidFill>
+                      <a:prstDash val="solid"/>
+                      <a:round/>
+                      <a:headEnd type="none" w="med" len="med"/>
+                      <a:tailEnd type="none" w="med" len="med"/>
+                    </a:lnB>
+                    <a:solidFill>
+                      <a:srgbClr val="F3F6F7"/>
+                    </a:solidFill>
+                  </a:tcPr>
+                </a:tc>
+                <a:tc>
+                  <a:txBody>
+                    <a:bodyPr/>
+                    <a:lstStyle/>
+                    <a:p>
+                      <a:pPr algn="ctr" indent="0" marL="0">
+                        <a:buNone/>
+                      </a:pPr>
+                      <a:r>
+                        <a:rPr lang="en-US" sz="1100" dirty="0">
+                          <a:solidFill>
+                            <a:srgbClr val="0F2D3A"/>
+                          </a:solidFill>
+                        </a:rPr>
+                        <a:t>50,54</a:t>
+                      </a:r>
+                      <a:endParaRPr lang="en-US" sz="1100" dirty="0"/>
+                    </a:p>
+                  </a:txBody>
+                  <a:tcPr marL="45720" marR="45720" marT="45720" marB="45720" anchor="ctr">
+                    <a:lnL w="6350" cap="flat" cmpd="sng" algn="ctr">
+                      <a:solidFill>
+                        <a:srgbClr val="D5E0E3"/>
+                      </a:solidFill>
+                      <a:prstDash val="solid"/>
+                      <a:round/>
+                      <a:headEnd type="none" w="med" len="med"/>
+                      <a:tailEnd type="none" w="med" len="med"/>
+                    </a:lnL>
+                    <a:lnR w="6350" cap="flat" cmpd="sng" algn="ctr">
+                      <a:solidFill>
+                        <a:srgbClr val="D5E0E3"/>
+                      </a:solidFill>
+                      <a:prstDash val="solid"/>
+                      <a:round/>
+                      <a:headEnd type="none" w="med" len="med"/>
+                      <a:tailEnd type="none" w="med" len="med"/>
+                    </a:lnR>
+                    <a:lnT w="6350" cap="flat" cmpd="sng" algn="ctr">
+                      <a:solidFill>
+                        <a:srgbClr val="D5E0E3"/>
+                      </a:solidFill>
+                      <a:prstDash val="solid"/>
+                      <a:round/>
+                      <a:headEnd type="none" w="med" len="med"/>
+                      <a:tailEnd type="none" w="med" len="med"/>
+                    </a:lnT>
+                    <a:lnB w="6350" cap="flat" cmpd="sng" algn="ctr">
+                      <a:solidFill>
+                        <a:srgbClr val="D5E0E3"/>
+                      </a:solidFill>
+                      <a:prstDash val="solid"/>
+                      <a:round/>
+                      <a:headEnd type="none" w="med" len="med"/>
+                      <a:tailEnd type="none" w="med" len="med"/>
+                    </a:lnB>
+                    <a:solidFill>
+                      <a:srgbClr val="F3F6F7"/>
                     </a:solidFill>
                   </a:tcPr>
                 </a:tc>
@@ -5546,42 +6048,6 @@
           </a:graphicData>
         </a:graphic>
       </p:graphicFrame>
-      <p:sp>
-        <p:nvSpPr>
-          <p:cNvPr id="6" name="Text 1"/>
-          <p:cNvSpPr txBox="1"/>
-          <p:nvPr/>
-        </p:nvSpPr>
-        <p:spPr>
-          <a:xfrm>
-            <a:off x="457200" y="2377440"/>
-            <a:ext cx="8229600" cy="228600"/>
-          </a:xfrm>
-          <a:prstGeom prst="rect">
-            <a:avLst/>
-          </a:prstGeom>
-          <a:noFill/>
-          <a:ln/>
-        </p:spPr>
-        <p:txBody>
-          <a:bodyPr wrap="square" lIns="0" tIns="0" rIns="0" bIns="0" rtlCol="0" anchor="ctr"/>
-          <a:lstStyle/>
-          <a:p>
-            <a:pPr indent="0" marL="0">
-              <a:buNone/>
-            </a:pPr>
-            <a:r>
-              <a:rPr lang="en-US" sz="1000" i="1" dirty="0">
-                <a:solidFill>
-                  <a:schemeClr val="accent1"/>
-                </a:solidFill>
-              </a:rPr>
-              <a:t>Демо-прогон без LLM: проверка обвязки эвала. Итоговые цифры — после прогона с моделями OpenRouter</a:t>
-            </a:r>
-            <a:endParaRPr lang="en-US" sz="1000" dirty="0"/>
-          </a:p>
-        </p:txBody>
-      </p:sp>
       <p:sp>
         <p:nvSpPr>
           <p:cNvPr id="25" name="Slide Number Placeholder 0"/>
@@ -5750,7 +6216,7 @@
                   <a:schemeClr val="accent1"/>
                 </a:solidFill>
               </a:rPr>
-              <a:t>−69%</a:t>
+              <a:t>−63%</a:t>
             </a:r>
             <a:endParaRPr lang="en-US" sz="4000" dirty="0"/>
           </a:p>
@@ -5786,7 +6252,7 @@
                   <a:schemeClr val="tx1"/>
                 </a:solidFill>
               </a:rPr>
-              <a:t>токенов на запрос после сжатия контекста (v1 → v2)</a:t>
+              <a:t>токенов на запрос: сжатие контекста (v1 → v3)</a:t>
             </a:r>
             <a:endParaRPr lang="en-US" sz="1200" dirty="0"/>
           </a:p>
@@ -5849,7 +6315,7 @@
                   <a:schemeClr val="accent1"/>
                 </a:solidFill>
               </a:rPr>
-              <a:t>+0.00</a:t>
+              <a:t>43 → 100%</a:t>
             </a:r>
             <a:endParaRPr lang="en-US" sz="4000" dirty="0"/>
           </a:p>
@@ -5885,7 +6351,7 @@
                   <a:schemeClr val="tx1"/>
                 </a:solidFill>
               </a:rPr>
-              <a:t>к качеству за счёт сверки и цикла исправлений (v1 → v2)</a:t>
+              <a:t>планов сходятся со всеми проверками</a:t>
             </a:r>
             <a:endParaRPr lang="en-US" sz="1200" dirty="0"/>
           </a:p>
@@ -5948,7 +6414,7 @@
                   <a:schemeClr val="accent1"/>
                 </a:solidFill>
               </a:rPr>
-              <a:t>—</a:t>
+              <a:t>$0.005</a:t>
             </a:r>
             <a:endParaRPr lang="en-US" sz="4000" dirty="0"/>
           </a:p>
@@ -5984,7 +6450,7 @@
                   <a:schemeClr val="tx1"/>
                 </a:solidFill>
               </a:rPr>
-              <a:t>качество v3 на лёгкой модели</a:t>
+              <a:t>за запрос на DeepSeek V4.1 Flash</a:t>
             </a:r>
             <a:endParaRPr lang="en-US" sz="1200" dirty="0"/>
           </a:p>
@@ -6060,7 +6526,7 @@
                   <a:schemeClr val="tx1"/>
                 </a:solidFill>
               </a:rPr>
-              <a:t>Валидатор ловит то, что модель «забыла»: выходной день музея, закат, последний рейс</a:t>
+              <a:t>Эвал нашёл 3 бага агента: обрезанный план, days строкой, зацикливание на невыполнимом запросе — исправлены в v3</a:t>
             </a:r>
             <a:endParaRPr lang="en-US" sz="1300" dirty="0"/>
           </a:p>
@@ -8820,7 +9286,7 @@
                 <a:ea typeface="Calibri" pitchFamily="34" charset="-122"/>
                 <a:cs typeface="Calibri" pitchFamily="34" charset="-120"/>
               </a:rPr>
-              <a:t>Амба сверит план с погодой, расписаниями и заправками — а грамоту можно взять с собой</a:t>
+              <a:t>Амба сверит план с погодой, расписаниями и заправками — а готовый план можно сохранить в PDF</a:t>
             </a:r>
             <a:endParaRPr lang="en-US" sz="1600" dirty="0"/>
           </a:p>
@@ -8883,7 +9349,7 @@
                 <a:ea typeface="Arial" pitchFamily="34" charset="-122"/>
                 <a:cs typeface="Arial" pitchFamily="34" charset="-120"/>
               </a:rPr>
-              <a:t>Писано тигрёнкомъ Амбою лѣта 7535</a:t>
+              <a:t>Хорошей дороги!</a:t>
             </a:r>
             <a:endParaRPr lang="en-US" sz="1200" dirty="0"/>
           </a:p>

</xml_diff>

<commit_message>
Street-level routes, booking links, real food places, clarifying questions, sea-style logbook
- Map routes use full OSRM geometry (streets and paths), approximate ones are dashed
- Server-side links: Yandex Maps and venue sites, Yandex Rasp tickets, hotels nearby
- find_food: real cafes and restaurants from OSM with cuisine, hours and website
- ask_user: one round of 1-2 short questions with options; skippable; prefilter covers answers
- Old-Russian manuscript replaced with a plain-language maritime 'logbook' view
- Tests: 96 backend, 7 frontend, 5 e2e

Co-Authored-By: Claude Opus 5.5 <noreply@anthropic.com>
</commit_message>
<xml_diff>
--- a/presentation/Amba_Travel_AI.pptx
+++ b/presentation/Amba_Travel_AI.pptx
@@ -121,18 +121,18 @@
   <p:extLst>
     <p:ext uri="{521415D9-36F7-43E2-AB2F-B90AF26B5E84}">
       <p14:sectionLst xmlns:p14="http://schemas.microsoft.com/office/powerpoint/2010/main">
-        <p14:section name="Начало" id="{55f83ce5-2c8c-0d70-bc69-07f9a223233c}">
+        <p14:section name="Начало" id="{cd4e261f-ee8e-5653-065d-2542f687d38c}">
           <p14:sldIdLst>
             <p14:sldId id="256"/>
           </p14:sldIdLst>
         </p14:section>
-        <p14:section name="Задача" id="{799d44a9-d8c1-e278-987e-670d39e1f5d9}">
+        <p14:section name="Задача" id="{da4cd4c1-ce68-30c5-311f-b5f072e72015}">
           <p14:sldIdLst>
             <p14:sldId id="257"/>
             <p14:sldId id="258"/>
           </p14:sldIdLst>
         </p14:section>
-        <p14:section name="Решение" id="{b2829937-d3a1-f9a6-ea09-bf5878568194}">
+        <p14:section name="Решение" id="{6a2d136d-300a-fed9-272f-b4d6f9c1253b}">
           <p14:sldIdLst>
             <p14:sldId id="259"/>
             <p14:sldId id="260"/>
@@ -142,19 +142,19 @@
             <p14:sldId id="264"/>
           </p14:sldIdLst>
         </p14:section>
-        <p14:section name="Замеры" id="{f16670f8-69df-c3b5-a63c-b4b78f7c6fd8}">
+        <p14:section name="Замеры" id="{74768c1c-0b3d-199e-622d-dfd242cc9162}">
           <p14:sldIdLst>
             <p14:sldId id="265"/>
             <p14:sldId id="266"/>
             <p14:sldId id="267"/>
           </p14:sldIdLst>
         </p14:section>
-        <p14:section name="Команда" id="{ced8fad4-d6ba-eaff-7fb7-bc38dcac5155}">
+        <p14:section name="Команда" id="{8c5e2ea5-95d4-7c02-4e15-572ad56a4805}">
           <p14:sldIdLst>
             <p14:sldId id="268"/>
           </p14:sldIdLst>
         </p14:section>
-        <p14:section name="Итоги" id="{24763dff-eef9-df12-c23c-cef3725aae67}">
+        <p14:section name="Итоги" id="{709635d0-98e4-b71e-1d37-b0e8afd13c24}">
           <p14:sldIdLst>
             <p14:sldId id="269"/>
             <p14:sldId id="270"/>
@@ -1896,7 +1896,7 @@
           <a:p>
             <a:r>
               <a:rPr lang="en-US" dirty="0"/>
-              <a:t>Демо: запрос «на 3 дня на машине в Хасанский район». Сверху то, что агент понял из запроса, статус сверки, дни таймлайном, справа карта и живые шаги агента. Одной кнопкой тот же план превращается в старорусскую грамоту.</a:t>
+              <a:t>Демо: запрос «на 3 дня на машине в Хасанский район». Сверху то, что агент понял из запроса, статус сверки, дни таймлайном, справа карта и живые шаги агента. У каждого пункта ссылки, чтобы сразу всё оформить. Одной кнопкой план переключается в морской «Бортовой журнал».</a:t>
             </a:r>
             <a:endParaRPr lang="en-US" dirty="0"/>
           </a:p>
@@ -12131,7 +12131,7 @@
       </p:pic>
       <p:pic>
         <p:nvPicPr>
-          <p:cNvPr id="4" name="manuscript.png" descr="preencoded.png">    </p:cNvPr>
+          <p:cNvPr id="4" name="logbook.png" descr="preencoded.png">    </p:cNvPr>
           <p:cNvPicPr>
             <a:picLocks noChangeAspect="1"/>
           </p:cNvPicPr>
@@ -12183,7 +12183,7 @@
                   <a:schemeClr val="accent1"/>
                 </a:solidFill>
               </a:rPr>
-              <a:t>Режим «Грамота»</a:t>
+              <a:t>Вид «Бортовой журнал»</a:t>
             </a:r>
             <a:endParaRPr lang="en-US" sz="1400" dirty="0"/>
           </a:p>
@@ -12219,7 +12219,7 @@
                   <a:schemeClr val="tx1"/>
                 </a:solidFill>
               </a:rPr>
-              <a:t>Тот же план в виде старорусской рукописи: буквица, ѣ и ъ, цифирь с титлом, печать «Свѣрено». Переключается одной кнопкой</a:t>
+              <a:t>Тот же план в морском стиле: компас, координаты точек, отметка «Маршрут проверен». Переключается одной кнопкой</a:t>
             </a:r>
             <a:endParaRPr lang="en-US" sz="1100" dirty="0"/>
           </a:p>
@@ -12255,7 +12255,7 @@
                   <a:schemeClr val="accent6"/>
                 </a:solidFill>
               </a:rPr>
-              <a:t>Слева — обычный вид: интенты из запроса, статус сверки, дни таймлайном, карта и шаги агента вживую</a:t>
+              <a:t>У каждого пункта ссылки: карта, сайт кафе, расписание и билеты, гостиницы рядом</a:t>
             </a:r>
             <a:endParaRPr lang="en-US" sz="1000" dirty="0"/>
           </a:p>
@@ -13002,7 +13002,7 @@
       </p:sp>
       <p:sp>
         <p:nvSpPr>
-          <p:cNvPr id="21" name="9 тулов"/>
+          <p:cNvPr id="21" name="10 тулов"/>
           <p:cNvSpPr/>
           <p:nvPr/>
         </p:nvSpPr>
@@ -13057,7 +13057,7 @@
                   <a:schemeClr val="tx1"/>
                 </a:solidFill>
               </a:rPr>
-              <a:t>9 тулов</a:t>
+              <a:t>10 тулов</a:t>
             </a:r>
             <a:endParaRPr lang="en-US" sz="1400" dirty="0"/>
           </a:p>
@@ -13093,7 +13093,7 @@
                   <a:schemeClr val="tx1"/>
                 </a:solidFill>
               </a:rPr>
-              <a:t>Реальные API: Open-Meteo, OSRM, Nominatim, Overpass, Википедия</a:t>
+              <a:t>Реальные API: Open-Meteo, OSRM, Nominatim (места и кафе), Overpass, Википедия</a:t>
             </a:r>
             <a:endParaRPr lang="en-US" sz="1100" dirty="0"/>
           </a:p>
@@ -13107,7 +13107,7 @@
                   <a:schemeClr val="tx1"/>
                 </a:solidFill>
               </a:rPr>
-              <a:t>Офлайн: места и часы работы, жильё, расписания, события</a:t>
+              <a:t>Офлайн: часы работы, жильё, расписания, события</a:t>
             </a:r>
             <a:endParaRPr lang="en-US" sz="1100" dirty="0"/>
           </a:p>
@@ -14595,7 +14595,7 @@
                 <a:gridCol w="2880360"/>
                 <a:gridCol w="1234440"/>
               </a:tblGrid>
-              <a:tr h="329184">
+              <a:tr h="301752">
                 <a:tc>
                   <a:txBody>
                     <a:bodyPr/>
@@ -14780,7 +14780,7 @@
                   </a:tcPr>
                 </a:tc>
               </a:tr>
-              <a:tr h="329184">
+              <a:tr h="301752">
                 <a:tc>
                   <a:txBody>
                     <a:bodyPr/>
@@ -14972,7 +14972,7 @@
                   </a:tcPr>
                 </a:tc>
               </a:tr>
-              <a:tr h="329184">
+              <a:tr h="301752">
                 <a:tc>
                   <a:txBody>
                     <a:bodyPr/>
@@ -15164,7 +15164,7 @@
                   </a:tcPr>
                 </a:tc>
               </a:tr>
-              <a:tr h="329184">
+              <a:tr h="301752">
                 <a:tc>
                   <a:txBody>
                     <a:bodyPr/>
@@ -15356,7 +15356,199 @@
                   </a:tcPr>
                 </a:tc>
               </a:tr>
-              <a:tr h="329184">
+              <a:tr h="301752">
+                <a:tc>
+                  <a:txBody>
+                    <a:bodyPr/>
+                    <a:lstStyle/>
+                    <a:p>
+                      <a:pPr indent="0" marL="0">
+                        <a:buNone/>
+                      </a:pPr>
+                      <a:r>
+                        <a:rPr lang="en-US" sz="1100" dirty="0">
+                          <a:solidFill>
+                            <a:srgbClr val="0F2D3A"/>
+                          </a:solidFill>
+                          <a:latin typeface="Courier New" pitchFamily="34" charset="0"/>
+                          <a:ea typeface="Courier New" pitchFamily="34" charset="-122"/>
+                          <a:cs typeface="Courier New" pitchFamily="34" charset="-120"/>
+                        </a:rPr>
+                        <a:t>find_food</a:t>
+                      </a:r>
+                      <a:endParaRPr lang="en-US" sz="1100" dirty="0">
+                        <a:latin typeface="Courier New" charset="0"/>
+                        <a:ea typeface="Courier New" charset="0"/>
+                        <a:cs typeface="Courier New" charset="0"/>
+                      </a:endParaRPr>
+                    </a:p>
+                  </a:txBody>
+                  <a:tcPr marL="54864" marR="54864" marT="54864" marB="54864" anchor="ctr">
+                    <a:lnL w="6350" cap="flat" cmpd="sng" algn="ctr">
+                      <a:solidFill>
+                        <a:srgbClr val="D5E0E3"/>
+                      </a:solidFill>
+                      <a:prstDash val="solid"/>
+                      <a:round/>
+                      <a:headEnd type="none" w="med" len="med"/>
+                      <a:tailEnd type="none" w="med" len="med"/>
+                    </a:lnL>
+                    <a:lnR w="6350" cap="flat" cmpd="sng" algn="ctr">
+                      <a:solidFill>
+                        <a:srgbClr val="D5E0E3"/>
+                      </a:solidFill>
+                      <a:prstDash val="solid"/>
+                      <a:round/>
+                      <a:headEnd type="none" w="med" len="med"/>
+                      <a:tailEnd type="none" w="med" len="med"/>
+                    </a:lnR>
+                    <a:lnT w="6350" cap="flat" cmpd="sng" algn="ctr">
+                      <a:solidFill>
+                        <a:srgbClr val="D5E0E3"/>
+                      </a:solidFill>
+                      <a:prstDash val="solid"/>
+                      <a:round/>
+                      <a:headEnd type="none" w="med" len="med"/>
+                      <a:tailEnd type="none" w="med" len="med"/>
+                    </a:lnT>
+                    <a:lnB w="6350" cap="flat" cmpd="sng" algn="ctr">
+                      <a:solidFill>
+                        <a:srgbClr val="D5E0E3"/>
+                      </a:solidFill>
+                      <a:prstDash val="solid"/>
+                      <a:round/>
+                      <a:headEnd type="none" w="med" len="med"/>
+                      <a:tailEnd type="none" w="med" len="med"/>
+                    </a:lnB>
+                    <a:solidFill>
+                      <a:srgbClr val="FFFFFF"/>
+                    </a:solidFill>
+                  </a:tcPr>
+                </a:tc>
+                <a:tc>
+                  <a:txBody>
+                    <a:bodyPr/>
+                    <a:lstStyle/>
+                    <a:p>
+                      <a:pPr indent="0" marL="0">
+                        <a:buNone/>
+                      </a:pPr>
+                      <a:r>
+                        <a:rPr lang="en-US" sz="1200" dirty="0">
+                          <a:solidFill>
+                            <a:srgbClr val="0F2D3A"/>
+                          </a:solidFill>
+                        </a:rPr>
+                        <a:t>Nominatim (OSM): кафе, кухня, сайт</a:t>
+                      </a:r>
+                      <a:endParaRPr lang="en-US" sz="1200" dirty="0"/>
+                    </a:p>
+                  </a:txBody>
+                  <a:tcPr marL="54864" marR="54864" marT="54864" marB="54864" anchor="ctr">
+                    <a:lnL w="6350" cap="flat" cmpd="sng" algn="ctr">
+                      <a:solidFill>
+                        <a:srgbClr val="D5E0E3"/>
+                      </a:solidFill>
+                      <a:prstDash val="solid"/>
+                      <a:round/>
+                      <a:headEnd type="none" w="med" len="med"/>
+                      <a:tailEnd type="none" w="med" len="med"/>
+                    </a:lnL>
+                    <a:lnR w="6350" cap="flat" cmpd="sng" algn="ctr">
+                      <a:solidFill>
+                        <a:srgbClr val="D5E0E3"/>
+                      </a:solidFill>
+                      <a:prstDash val="solid"/>
+                      <a:round/>
+                      <a:headEnd type="none" w="med" len="med"/>
+                      <a:tailEnd type="none" w="med" len="med"/>
+                    </a:lnR>
+                    <a:lnT w="6350" cap="flat" cmpd="sng" algn="ctr">
+                      <a:solidFill>
+                        <a:srgbClr val="D5E0E3"/>
+                      </a:solidFill>
+                      <a:prstDash val="solid"/>
+                      <a:round/>
+                      <a:headEnd type="none" w="med" len="med"/>
+                      <a:tailEnd type="none" w="med" len="med"/>
+                    </a:lnT>
+                    <a:lnB w="6350" cap="flat" cmpd="sng" algn="ctr">
+                      <a:solidFill>
+                        <a:srgbClr val="D5E0E3"/>
+                      </a:solidFill>
+                      <a:prstDash val="solid"/>
+                      <a:round/>
+                      <a:headEnd type="none" w="med" len="med"/>
+                      <a:tailEnd type="none" w="med" len="med"/>
+                    </a:lnB>
+                    <a:solidFill>
+                      <a:srgbClr val="FFFFFF"/>
+                    </a:solidFill>
+                  </a:tcPr>
+                </a:tc>
+                <a:tc>
+                  <a:txBody>
+                    <a:bodyPr/>
+                    <a:lstStyle/>
+                    <a:p>
+                      <a:pPr indent="0" marL="0">
+                        <a:buNone/>
+                      </a:pPr>
+                      <a:r>
+                        <a:rPr lang="en-US" sz="1200" b="1" dirty="0">
+                          <a:solidFill>
+                            <a:srgbClr val="2E6B62"/>
+                          </a:solidFill>
+                        </a:rPr>
+                        <a:t>реальный</a:t>
+                      </a:r>
+                      <a:endParaRPr lang="en-US" sz="1200" dirty="0"/>
+                    </a:p>
+                  </a:txBody>
+                  <a:tcPr marL="54864" marR="54864" marT="54864" marB="54864" anchor="ctr">
+                    <a:lnL w="6350" cap="flat" cmpd="sng" algn="ctr">
+                      <a:solidFill>
+                        <a:srgbClr val="D5E0E3"/>
+                      </a:solidFill>
+                      <a:prstDash val="solid"/>
+                      <a:round/>
+                      <a:headEnd type="none" w="med" len="med"/>
+                      <a:tailEnd type="none" w="med" len="med"/>
+                    </a:lnL>
+                    <a:lnR w="6350" cap="flat" cmpd="sng" algn="ctr">
+                      <a:solidFill>
+                        <a:srgbClr val="D5E0E3"/>
+                      </a:solidFill>
+                      <a:prstDash val="solid"/>
+                      <a:round/>
+                      <a:headEnd type="none" w="med" len="med"/>
+                      <a:tailEnd type="none" w="med" len="med"/>
+                    </a:lnR>
+                    <a:lnT w="6350" cap="flat" cmpd="sng" algn="ctr">
+                      <a:solidFill>
+                        <a:srgbClr val="D5E0E3"/>
+                      </a:solidFill>
+                      <a:prstDash val="solid"/>
+                      <a:round/>
+                      <a:headEnd type="none" w="med" len="med"/>
+                      <a:tailEnd type="none" w="med" len="med"/>
+                    </a:lnT>
+                    <a:lnB w="6350" cap="flat" cmpd="sng" algn="ctr">
+                      <a:solidFill>
+                        <a:srgbClr val="D5E0E3"/>
+                      </a:solidFill>
+                      <a:prstDash val="solid"/>
+                      <a:round/>
+                      <a:headEnd type="none" w="med" len="med"/>
+                      <a:tailEnd type="none" w="med" len="med"/>
+                    </a:lnB>
+                    <a:solidFill>
+                      <a:srgbClr val="FFFFFF"/>
+                    </a:solidFill>
+                  </a:tcPr>
+                </a:tc>
+              </a:tr>
+              <a:tr h="301752">
                 <a:tc>
                   <a:txBody>
                     <a:bodyPr/>
@@ -15421,7 +15613,7 @@
                       <a:tailEnd type="none" w="med" len="med"/>
                     </a:lnB>
                     <a:solidFill>
-                      <a:srgbClr val="FFFFFF"/>
+                      <a:srgbClr val="F3F6F7"/>
                     </a:solidFill>
                   </a:tcPr>
                 </a:tc>
@@ -15482,7 +15674,7 @@
                       <a:tailEnd type="none" w="med" len="med"/>
                     </a:lnB>
                     <a:solidFill>
-                      <a:srgbClr val="FFFFFF"/>
+                      <a:srgbClr val="F3F6F7"/>
                     </a:solidFill>
                   </a:tcPr>
                 </a:tc>
@@ -15543,12 +15735,12 @@
                       <a:tailEnd type="none" w="med" len="med"/>
                     </a:lnB>
                     <a:solidFill>
-                      <a:srgbClr val="FFFFFF"/>
+                      <a:srgbClr val="F3F6F7"/>
                     </a:solidFill>
                   </a:tcPr>
                 </a:tc>
               </a:tr>
-              <a:tr h="329184">
+              <a:tr h="301752">
                 <a:tc>
                   <a:txBody>
                     <a:bodyPr/>
@@ -15613,7 +15805,7 @@
                       <a:tailEnd type="none" w="med" len="med"/>
                     </a:lnB>
                     <a:solidFill>
-                      <a:srgbClr val="F3F6F7"/>
+                      <a:srgbClr val="FFFFFF"/>
                     </a:solidFill>
                   </a:tcPr>
                 </a:tc>
@@ -15674,7 +15866,7 @@
                       <a:tailEnd type="none" w="med" len="med"/>
                     </a:lnB>
                     <a:solidFill>
-                      <a:srgbClr val="F3F6F7"/>
+                      <a:srgbClr val="FFFFFF"/>
                     </a:solidFill>
                   </a:tcPr>
                 </a:tc>
@@ -15735,12 +15927,12 @@
                       <a:tailEnd type="none" w="med" len="med"/>
                     </a:lnB>
                     <a:solidFill>
-                      <a:srgbClr val="F3F6F7"/>
+                      <a:srgbClr val="FFFFFF"/>
                     </a:solidFill>
                   </a:tcPr>
                 </a:tc>
               </a:tr>
-              <a:tr h="329184">
+              <a:tr h="301752">
                 <a:tc>
                   <a:txBody>
                     <a:bodyPr/>
@@ -15805,7 +15997,7 @@
                       <a:tailEnd type="none" w="med" len="med"/>
                     </a:lnB>
                     <a:solidFill>
-                      <a:srgbClr val="FFFFFF"/>
+                      <a:srgbClr val="F3F6F7"/>
                     </a:solidFill>
                   </a:tcPr>
                 </a:tc>
@@ -15866,7 +16058,7 @@
                       <a:tailEnd type="none" w="med" len="med"/>
                     </a:lnB>
                     <a:solidFill>
-                      <a:srgbClr val="FFFFFF"/>
+                      <a:srgbClr val="F3F6F7"/>
                     </a:solidFill>
                   </a:tcPr>
                 </a:tc>
@@ -15927,12 +16119,12 @@
                       <a:tailEnd type="none" w="med" len="med"/>
                     </a:lnB>
                     <a:solidFill>
-                      <a:srgbClr val="FFFFFF"/>
+                      <a:srgbClr val="F3F6F7"/>
                     </a:solidFill>
                   </a:tcPr>
                 </a:tc>
               </a:tr>
-              <a:tr h="329184">
+              <a:tr h="301752">
                 <a:tc>
                   <a:txBody>
                     <a:bodyPr/>
@@ -15997,7 +16189,7 @@
                       <a:tailEnd type="none" w="med" len="med"/>
                     </a:lnB>
                     <a:solidFill>
-                      <a:srgbClr val="F3F6F7"/>
+                      <a:srgbClr val="FFFFFF"/>
                     </a:solidFill>
                   </a:tcPr>
                 </a:tc>
@@ -16058,7 +16250,7 @@
                       <a:tailEnd type="none" w="med" len="med"/>
                     </a:lnB>
                     <a:solidFill>
-                      <a:srgbClr val="F3F6F7"/>
+                      <a:srgbClr val="FFFFFF"/>
                     </a:solidFill>
                   </a:tcPr>
                 </a:tc>
@@ -16119,12 +16311,12 @@
                       <a:tailEnd type="none" w="med" len="med"/>
                     </a:lnB>
                     <a:solidFill>
-                      <a:srgbClr val="F3F6F7"/>
+                      <a:srgbClr val="FFFFFF"/>
                     </a:solidFill>
                   </a:tcPr>
                 </a:tc>
               </a:tr>
-              <a:tr h="329184">
+              <a:tr h="301752">
                 <a:tc>
                   <a:txBody>
                     <a:bodyPr/>
@@ -16189,7 +16381,7 @@
                       <a:tailEnd type="none" w="med" len="med"/>
                     </a:lnB>
                     <a:solidFill>
-                      <a:srgbClr val="FFFFFF"/>
+                      <a:srgbClr val="F3F6F7"/>
                     </a:solidFill>
                   </a:tcPr>
                 </a:tc>
@@ -16250,7 +16442,7 @@
                       <a:tailEnd type="none" w="med" len="med"/>
                     </a:lnB>
                     <a:solidFill>
-                      <a:srgbClr val="FFFFFF"/>
+                      <a:srgbClr val="F3F6F7"/>
                     </a:solidFill>
                   </a:tcPr>
                 </a:tc>
@@ -16311,12 +16503,12 @@
                       <a:tailEnd type="none" w="med" len="med"/>
                     </a:lnB>
                     <a:solidFill>
-                      <a:srgbClr val="FFFFFF"/>
+                      <a:srgbClr val="F3F6F7"/>
                     </a:solidFill>
                   </a:tcPr>
                 </a:tc>
               </a:tr>
-              <a:tr h="329184">
+              <a:tr h="301752">
                 <a:tc>
                   <a:txBody>
                     <a:bodyPr/>
@@ -16381,7 +16573,7 @@
                       <a:tailEnd type="none" w="med" len="med"/>
                     </a:lnB>
                     <a:solidFill>
-                      <a:srgbClr val="F3F6F7"/>
+                      <a:srgbClr val="FFFFFF"/>
                     </a:solidFill>
                   </a:tcPr>
                 </a:tc>
@@ -16442,7 +16634,7 @@
                       <a:tailEnd type="none" w="med" len="med"/>
                     </a:lnB>
                     <a:solidFill>
-                      <a:srgbClr val="F3F6F7"/>
+                      <a:srgbClr val="FFFFFF"/>
                     </a:solidFill>
                   </a:tcPr>
                 </a:tc>
@@ -16503,7 +16695,7 @@
                       <a:tailEnd type="none" w="med" len="med"/>
                     </a:lnB>
                     <a:solidFill>
-                      <a:srgbClr val="F3F6F7"/>
+                      <a:srgbClr val="FFFFFF"/>
                     </a:solidFill>
                   </a:tcPr>
                 </a:tc>

</xml_diff>

<commit_message>
Deck: final-slide QR is a Rutube easter egg; demo QR on slide 11 unchanged
Co-Authored-By: Claude Opus 5.5 <noreply@anthropic.com>
</commit_message>
<xml_diff>
--- a/presentation/Amba_Travel_AI.pptx
+++ b/presentation/Amba_Travel_AI.pptx
@@ -118,18 +118,18 @@
   <p:extLst>
     <p:ext uri="{521415D9-36F7-43E2-AB2F-B90AF26B5E84}">
       <p14:sectionLst xmlns:p14="http://schemas.microsoft.com/office/powerpoint/2010/main">
-        <p14:section name="Начало" id="{72c25d14-9d06-3b07-c245-1d5383509611}">
+        <p14:section name="Начало" id="{68b9d785-0606-c10d-9fad-f31553f473be}">
           <p14:sldIdLst>
             <p14:sldId id="256"/>
           </p14:sldIdLst>
         </p14:section>
-        <p14:section name="Задача" id="{cd108198-0f5d-f42d-f141-e2d8a7cec34f}">
+        <p14:section name="Задача" id="{b0b1bade-1c7e-7c8b-dcf5-48dd068d6941}">
           <p14:sldIdLst>
             <p14:sldId id="257"/>
             <p14:sldId id="258"/>
           </p14:sldIdLst>
         </p14:section>
-        <p14:section name="Решение" id="{3f7c07b1-0769-8b31-75cb-9d0502ec3f0a}">
+        <p14:section name="Решение" id="{0ae5ad04-9cb5-b8c8-b329-6efbf0f5d369}">
           <p14:sldIdLst>
             <p14:sldId id="259"/>
             <p14:sldId id="260"/>
@@ -137,18 +137,18 @@
             <p14:sldId id="262"/>
           </p14:sldIdLst>
         </p14:section>
-        <p14:section name="Замеры" id="{510fa9e0-358e-772c-c6d0-67e8f144319c}">
+        <p14:section name="Замеры" id="{d1f19482-9be7-5e8d-a97a-41b4d2c34962}">
           <p14:sldIdLst>
             <p14:sldId id="263"/>
             <p14:sldId id="264"/>
           </p14:sldIdLst>
         </p14:section>
-        <p14:section name="Команда" id="{f60041b7-69b4-049a-84e0-36f46f39b9c1}">
+        <p14:section name="Команда" id="{9fcbecf6-56c2-d7c2-f042-35405b3c6317}">
           <p14:sldIdLst>
             <p14:sldId id="265"/>
           </p14:sldIdLst>
         </p14:section>
-        <p14:section name="Итоги" id="{440d3599-b774-37cc-f57d-d9cce8639bfe}">
+        <p14:section name="Итоги" id="{55186cd4-f36f-f7e8-d150-45af7da119c3}">
           <p14:sldIdLst>
             <p14:sldId id="266"/>
             <p14:sldId id="267"/>

</xml_diff>

<commit_message>
Ad-free easter egg page on GitHub Pages; final QR points to it
Co-Authored-By: Claude Opus 5.5 <noreply@anthropic.com>
</commit_message>
<xml_diff>
--- a/presentation/Amba_Travel_AI.pptx
+++ b/presentation/Amba_Travel_AI.pptx
@@ -118,18 +118,18 @@
   <p:extLst>
     <p:ext uri="{521415D9-36F7-43E2-AB2F-B90AF26B5E84}">
       <p14:sectionLst xmlns:p14="http://schemas.microsoft.com/office/powerpoint/2010/main">
-        <p14:section name="Начало" id="{68b9d785-0606-c10d-9fad-f31553f473be}">
+        <p14:section name="Начало" id="{a53a9f18-68cf-11c8-128c-2d5dc4fce491}">
           <p14:sldIdLst>
             <p14:sldId id="256"/>
           </p14:sldIdLst>
         </p14:section>
-        <p14:section name="Задача" id="{b0b1bade-1c7e-7c8b-dcf5-48dd068d6941}">
+        <p14:section name="Задача" id="{ad494c9a-0b08-322d-a968-917bdaf5b72b}">
           <p14:sldIdLst>
             <p14:sldId id="257"/>
             <p14:sldId id="258"/>
           </p14:sldIdLst>
         </p14:section>
-        <p14:section name="Решение" id="{0ae5ad04-9cb5-b8c8-b329-6efbf0f5d369}">
+        <p14:section name="Решение" id="{bbbad43e-4ae3-41f7-296c-59b297608eb3}">
           <p14:sldIdLst>
             <p14:sldId id="259"/>
             <p14:sldId id="260"/>
@@ -137,18 +137,18 @@
             <p14:sldId id="262"/>
           </p14:sldIdLst>
         </p14:section>
-        <p14:section name="Замеры" id="{d1f19482-9be7-5e8d-a97a-41b4d2c34962}">
+        <p14:section name="Замеры" id="{00b71219-c60c-8af1-4a48-0d856c412d84}">
           <p14:sldIdLst>
             <p14:sldId id="263"/>
             <p14:sldId id="264"/>
           </p14:sldIdLst>
         </p14:section>
-        <p14:section name="Команда" id="{9fcbecf6-56c2-d7c2-f042-35405b3c6317}">
+        <p14:section name="Команда" id="{6d2d6cd0-06f0-eaa3-f34d-06c53afddf45}">
           <p14:sldIdLst>
             <p14:sldId id="265"/>
           </p14:sldIdLst>
         </p14:section>
-        <p14:section name="Итоги" id="{55186cd4-f36f-f7e8-d150-45af7da119c3}">
+        <p14:section name="Итоги" id="{9b0c520e-3fc8-6d14-cc7c-dc1b8a6808ce}">
           <p14:sldIdLst>
             <p14:sldId id="266"/>
             <p14:sldId id="267"/>

</xml_diff>

<commit_message>
Deck in the official T-Bank Education template; rickroll QR points to a direct ad-free mp4
- build_tbank.py fills 12 template slides (cover, two-column, table, laptop mockup, numbered cards,
  plus/minus, metrics, accent number, team chart, contacts with QR, thank-you) and puts the 7:35 talk in notes
- Mascot on the cover and the final slide, avatars for the team

Co-Authored-By: Claude Opus 5.5 <noreply@anthropic.com>
</commit_message>
<xml_diff>
--- a/presentation/Amba_Travel_AI.pptx
+++ b/presentation/Amba_Travel_AI.pptx
@@ -118,18 +118,18 @@
   <p:extLst>
     <p:ext uri="{521415D9-36F7-43E2-AB2F-B90AF26B5E84}">
       <p14:sectionLst xmlns:p14="http://schemas.microsoft.com/office/powerpoint/2010/main">
-        <p14:section name="Начало" id="{a53a9f18-68cf-11c8-128c-2d5dc4fce491}">
+        <p14:section name="Начало" id="{2e90688d-574c-18c0-79dd-45628652b439}">
           <p14:sldIdLst>
             <p14:sldId id="256"/>
           </p14:sldIdLst>
         </p14:section>
-        <p14:section name="Задача" id="{ad494c9a-0b08-322d-a968-917bdaf5b72b}">
+        <p14:section name="Задача" id="{83777072-8378-e08e-7a9d-0c7b8e96fba5}">
           <p14:sldIdLst>
             <p14:sldId id="257"/>
             <p14:sldId id="258"/>
           </p14:sldIdLst>
         </p14:section>
-        <p14:section name="Решение" id="{bbbad43e-4ae3-41f7-296c-59b297608eb3}">
+        <p14:section name="Решение" id="{7ef3efa7-aada-c695-797a-4223646397ad}">
           <p14:sldIdLst>
             <p14:sldId id="259"/>
             <p14:sldId id="260"/>
@@ -137,18 +137,18 @@
             <p14:sldId id="262"/>
           </p14:sldIdLst>
         </p14:section>
-        <p14:section name="Замеры" id="{00b71219-c60c-8af1-4a48-0d856c412d84}">
+        <p14:section name="Замеры" id="{f3afaca9-cc39-5655-e42e-77669cd040db}">
           <p14:sldIdLst>
             <p14:sldId id="263"/>
             <p14:sldId id="264"/>
           </p14:sldIdLst>
         </p14:section>
-        <p14:section name="Команда" id="{6d2d6cd0-06f0-eaa3-f34d-06c53afddf45}">
+        <p14:section name="Команда" id="{45f56791-773a-fbd1-c6a7-7c3fa142a50b}">
           <p14:sldIdLst>
             <p14:sldId id="265"/>
           </p14:sldIdLst>
         </p14:section>
-        <p14:section name="Итоги" id="{9b0c520e-3fc8-6d14-cc7c-dc1b8a6808ce}">
+        <p14:section name="Итоги" id="{75cf3900-1107-f23d-5739-fb1fcda29088}">
           <p14:sldIdLst>
             <p14:sldId id="266"/>
             <p14:sldId id="267"/>

</xml_diff>

<commit_message>
Redis rate limiting and plan refinement in a dialog with the client
- store.py: Redis (shared counters, dialog history with TTL) with in-memory fallback when Redis is down
- Rate limits on plans per IP and per user (configurable), auth and mail limits now in Redis; 429 with Retry-After
- Dialog: 'cheaper', 'drop the museum', 'by train' — the agent edits the current plan with full context,
  intents of the follow-up override the original, validation runs again; saved trip is updated in place
- Chat under the plan with quick chips; errors stay in the chat and keep the plan on screen
- docker-compose: Redis service (memory-only), app waits for it; /api/health reports the store
- Mobile toolbar overflow fix; 10 new backend tests (fakeredis) and a chat e2e test
- README and both decks mention dialog refinement and Redis limits

Co-Authored-By: Claude Opus 5.5 <noreply@anthropic.com>
</commit_message>
<xml_diff>
--- a/presentation/Amba_Travel_AI.pptx
+++ b/presentation/Amba_Travel_AI.pptx
@@ -118,18 +118,18 @@
   <p:extLst>
     <p:ext uri="{521415D9-36F7-43E2-AB2F-B90AF26B5E84}">
       <p14:sectionLst xmlns:p14="http://schemas.microsoft.com/office/powerpoint/2010/main">
-        <p14:section name="Начало" id="{2e90688d-574c-18c0-79dd-45628652b439}">
+        <p14:section name="Начало" id="{12feb9ea-ce08-8dbc-0b1a-f99d7c0fd7a9}">
           <p14:sldIdLst>
             <p14:sldId id="256"/>
           </p14:sldIdLst>
         </p14:section>
-        <p14:section name="Задача" id="{83777072-8378-e08e-7a9d-0c7b8e96fba5}">
+        <p14:section name="Задача" id="{1632df76-448f-777b-6ad2-e6aa817efe6f}">
           <p14:sldIdLst>
             <p14:sldId id="257"/>
             <p14:sldId id="258"/>
           </p14:sldIdLst>
         </p14:section>
-        <p14:section name="Решение" id="{7ef3efa7-aada-c695-797a-4223646397ad}">
+        <p14:section name="Решение" id="{ccc146b5-cc50-af38-c804-7fb1560e45e8}">
           <p14:sldIdLst>
             <p14:sldId id="259"/>
             <p14:sldId id="260"/>
@@ -137,18 +137,18 @@
             <p14:sldId id="262"/>
           </p14:sldIdLst>
         </p14:section>
-        <p14:section name="Замеры" id="{f3afaca9-cc39-5655-e42e-77669cd040db}">
+        <p14:section name="Замеры" id="{90ded53e-7d4c-b43e-9330-a550e64c15e2}">
           <p14:sldIdLst>
             <p14:sldId id="263"/>
             <p14:sldId id="264"/>
           </p14:sldIdLst>
         </p14:section>
-        <p14:section name="Команда" id="{45f56791-773a-fbd1-c6a7-7c3fa142a50b}">
+        <p14:section name="Команда" id="{7f4173de-a595-2b2e-5fc1-eb1eb47bb7b5}">
           <p14:sldIdLst>
             <p14:sldId id="265"/>
           </p14:sldIdLst>
         </p14:section>
-        <p14:section name="Итоги" id="{75cf3900-1107-f23d-5739-fb1fcda29088}">
+        <p14:section name="Итоги" id="{f9fa4ec0-dbca-15d1-9ec7-9103a86d716f}">
           <p14:sldIdLst>
             <p14:sldId id="266"/>
             <p14:sldId id="267"/>
@@ -1604,7 +1604,7 @@
           <a:p>
             <a:r>
               <a:rPr lang="en-US" dirty="0"/>
-              <a:t>[0:50 · к концу слайда 2:35] Вот как это выглядит. Человек пишет: «на три дня на машине в Хасанский район». Если чего-то не хватает, Амба коротко уточняет, например какую кухню вы любите. Дальше видно, что агент понял из запроса, статус проверки, дни таймлайном и маршрут на карте — по улицам, а не напрямик. Обеды — реальные кафе из OpenStreetMap. У каждого пункта есть ссылки: карта, сайт, расписание и билеты, гостиницы рядом. Демо открыто по ссылке на последнем слайде.</a:t>
+              <a:t>[0:50 · к концу слайда 2:35] Вот как это выглядит. Человек пишет: «на три дня на машине в Хасанский район». Если чего-то не хватает, Амба коротко уточняет, например какую кухню вы любите. Дальше видно, что агент понял из запроса, статус проверки, дни таймлайном и маршрут на карте — по улицам, а не напрямик. Обеды — реальные кафе из OpenStreetMap, у каждого пункта ссылки. А если что-то не понравилось, план можно доработать прямо в чате: «подешевле», «убери музей».</a:t>
             </a:r>
             <a:endParaRPr lang="en-US" dirty="0"/>
           </a:p>
@@ -1692,7 +1692,7 @@
           <a:p>
             <a:r>
               <a:rPr lang="en-US" dirty="0"/>
-              <a:t>[0:50 · к концу слайда 3:25] Это не один промпт, а агентный цикл. Сначала фильтр: всё, что не про Приморье, отклоняется без вызова модели. Если важного не хватает, агент задаёт один-два вопроса. Дальше модель сама выбирает тулы, мы вызываем их параллельно и возвращаем данные, и так по кругу, пока данных не хватит. Готовый план проходит проверку; если есть противоречия, агент их исправляет. Цикл написан с нуля на FastAPI, модель — DeepSeek через OpenRouter.</a:t>
+              <a:t>[0:50 · к концу слайда 3:25] Это не один промпт, а агентный цикл. Сначала фильтр: всё, что не про Приморье, отклоняется без вызова модели. Если важного не хватает, агент задаёт один-два вопроса, а после плана с ним можно продолжить диалог. Дальше модель сама выбирает тулы, мы вызываем их параллельно и возвращаем данные, и так по кругу, пока данных не хватит. Готовый план проходит проверку; если есть противоречия, агент их исправляет. Цикл написан с нуля на FastAPI, модель — DeepSeek через OpenRouter.</a:t>
             </a:r>
             <a:endParaRPr lang="en-US" dirty="0"/>
           </a:p>
@@ -1868,7 +1868,7 @@
           <a:p>
             <a:r>
               <a:rPr lang="en-US" dirty="0"/>
-              <a:t>[0:50 · к концу слайда 4:50] Главное правило задания — план должен сходиться. Проверку делает код, а не модель: для пешехода — не больше двадцати километров и до заката, для велосипеда — не в дождь, для автобуса — рейс реально ходит и вы успеваете на последний, для машины — по пути есть заправки. Плюс сроки, ночёвка, режим работы, погода. И Амба говорит только о Приморье: алгебру, Сочи и «забудь правила» вежливо отклоняет, а поездку из Хабаровска во Владивосток спокойно планирует.</a:t>
+              <a:t>[0:50 · к концу слайда 4:50] Главное правило задания — план должен сходиться. Проверку делает код, а не модель: для пешехода — не больше двадцати километров и до заката, для велосипеда — не в дождь, для автобуса — рейс реально ходит и вы успеваете на последний, для машины — по пути есть заправки. Плюс сроки, ночёвка, режим работы, погода. И Амба говорит только о Приморье: алгебру, Сочи и «забудь правила» вежливо отклоняет. От спама стоят лимиты запросов в Redis.</a:t>
             </a:r>
             <a:endParaRPr lang="en-US" dirty="0"/>
           </a:p>

</xml_diff>